<commit_message>
Rewrite presentation deck in plain language (ELI5), proper nouns kept
Slide copy simplified throughout — jargon replaced with everyday
wording ("mapping workbook" -> "spreadsheet", "verbatim grounding
audit" -> "it shows its work", "gated ambiguity" -> "sets the
question aside", "anonymized fixture" -> "scrubbed practice
document") — while keeping every proper noun (FRD, STTM, BRD,
CodeGen, Code Review, SQL Optimization, Claude, Databricks, Unity
Catalog, Delta, AmeriHealth, Hexaware, Soham, Arjun) and every
sourced figure unchanged. Same 13-slide structure, layout and
theme; speaker notes stay technical (presenter cue cards). Also
picks up the corrected test count (77 collected).

Co-Authored-By: Claude Fable 5 <noreply@anthropic.com>
</commit_message>
<xml_diff>
--- a/docs/FRD_to_STTM_Agent_Demo.pptx
+++ b/docs/FRD_to_STTM_Agent_Demo.pptx
@@ -1390,7 +1390,7 @@
               <a:rPr sz="1200">
                 <a:latin typeface="Calibri"/>
               </a:rPr>
-              <a:t>If pushed on the difference between strict and advisory: strict fields are identifiers and must match verbatim; advisory fields are prose and are checked by token overlap.</a:t>
+              <a:t>If pushed on the difference between strict and softer checks: strict fields are identifiers and must match verbatim; the softer (advisory) fields are prose and are checked by token overlap.</a:t>
             </a:r>
           </a:p>
         </p:txBody>
@@ -4970,8 +4970,8 @@
                 </a:solidFill>
                 <a:latin typeface="Calibri"/>
               </a:rPr>
-              <a:t>From an approved Functional Requirements Document to a governed
-Source-to-Target Mapping workbook — in about thirty seconds.</a:t>
+              <a:t>It reads an approved FRD document and builds the STTM mapping
+spreadsheet for you — in about thirty seconds.</a:t>
             </a:r>
           </a:p>
         </p:txBody>
@@ -5149,7 +5149,7 @@
                 </a:solidFill>
                 <a:latin typeface="Calibri"/>
               </a:rPr>
-              <a:t>cell-level mapping fidelity</a:t>
+              <a:t>of spreadsheet cells match the</a:t>
             </a:r>
           </a:p>
           <a:p>
@@ -5171,7 +5171,7 @@
                 </a:solidFill>
                 <a:latin typeface="Calibri"/>
               </a:rPr>
-              <a:t>vs. the golden reference</a:t>
+              <a:t>hand-made answer sheet</a:t>
             </a:r>
           </a:p>
         </p:txBody>
@@ -5238,7 +5238,7 @@
                 </a:solidFill>
                 <a:latin typeface="Calibri"/>
               </a:rPr>
-              <a:t>ungrounded identifiers</a:t>
+              <a:t>names checked — every single</a:t>
             </a:r>
           </a:p>
           <a:p>
@@ -5260,7 +5260,7 @@
                 </a:solidFill>
                 <a:latin typeface="Calibri"/>
               </a:rPr>
-              <a:t>in the hallucination sweep</a:t>
+              <a:t>one is really in the document</a:t>
             </a:r>
           </a:p>
         </p:txBody>
@@ -5327,7 +5327,7 @@
                 </a:solidFill>
                 <a:latin typeface="Calibri"/>
               </a:rPr>
-              <a:t>full pipeline, one billed</a:t>
+              <a:t>start to finish, one paid AI</a:t>
             </a:r>
           </a:p>
           <a:p>
@@ -5349,7 +5349,7 @@
                 </a:solidFill>
                 <a:latin typeface="Calibri"/>
               </a:rPr>
-              <a:t>model call (about $0.15)</a:t>
+              <a:t>call (about 15 cents)</a:t>
             </a:r>
           </a:p>
         </p:txBody>
@@ -5394,8 +5394,8 @@
                 </a:solidFill>
                 <a:latin typeface="Calibri"/>
               </a:rPr>
-              <a:t>Measured on the anonymized demo pair — live
-end-to-end run, 7 August 2026</a:t>
+              <a:t>Measured on a scrubbed practice document —
+real run, 7 August 2026</a:t>
             </a:r>
           </a:p>
         </p:txBody>
@@ -5815,7 +5815,7 @@
                 </a:solidFill>
                 <a:latin typeface="Calibri"/>
               </a:rPr>
-              <a:t>The hand-built workbook is the slowest step between an approved FRD and working pipeline code. The agent produces it in about thirty seconds.</a:t>
+              <a:t>The spreadsheet is the slowest step between an approved FRD and working code. The agent makes it in about thirty seconds.</a:t>
             </a:r>
           </a:p>
           <a:p>
@@ -5837,7 +5837,7 @@
                 </a:solidFill>
                 <a:latin typeface="Calibri"/>
               </a:rPr>
-              <a:t>Analysts move from transcription to review — the part that needs their expertise.</a:t>
+              <a:t>Your people go from typing to checking — the part that actually needs their judgement.</a:t>
             </a:r>
           </a:p>
         </p:txBody>
@@ -5972,7 +5972,7 @@
                 </a:solidFill>
                 <a:latin typeface="Calibri"/>
               </a:rPr>
-              <a:t>Auditable by construction</a:t>
+              <a:t>Easy to audit</a:t>
             </a:r>
           </a:p>
         </p:txBody>
@@ -6017,7 +6017,7 @@
                 </a:solidFill>
                 <a:latin typeface="Calibri"/>
               </a:rPr>
-              <a:t>Every value is traced verbatim to the sentence that justified it, and that check is a hard gate on every run.</a:t>
+              <a:t>Every value points back to the sentence it came from, and that check runs on every single document.</a:t>
             </a:r>
           </a:p>
           <a:p>
@@ -6039,7 +6039,7 @@
                 </a:solidFill>
                 <a:latin typeface="Calibri"/>
               </a:rPr>
-              <a:t>When an auditor asks why a field maps the way it does, the answer is recorded, not reconstructed.</a:t>
+              <a:t>When an auditor asks "why is this mapped that way?", the answer is already written down.</a:t>
             </a:r>
           </a:p>
         </p:txBody>
@@ -6174,7 +6174,7 @@
                 </a:solidFill>
                 <a:latin typeface="Calibri"/>
               </a:rPr>
-              <a:t>Consistent across teams</a:t>
+              <a:t>Same result every time</a:t>
             </a:r>
           </a:p>
         </p:txBody>
@@ -6219,7 +6219,7 @@
                 </a:solidFill>
                 <a:latin typeface="Calibri"/>
               </a:rPr>
-              <a:t>Two analysts reading one FRD produce two workbooks. The agent produces the same structure every time.</a:t>
+              <a:t>Two people make two different spreadsheets. The agent makes the same one every time, from the same rules.</a:t>
             </a:r>
           </a:p>
           <a:p>
@@ -6241,7 +6241,7 @@
                 </a:solidFill>
                 <a:latin typeface="Calibri"/>
               </a:rPr>
-              <a:t>Naming, load strategies and rule attribution stop drifting — which is what makes downstream automation possible.</a:t>
+              <a:t>Names and rules stop drifting between teams — which is what lets the later steps be automated too.</a:t>
             </a:r>
           </a:p>
         </p:txBody>
@@ -6421,7 +6421,7 @@
                 </a:solidFill>
                 <a:latin typeface="Calibri"/>
               </a:rPr>
-              <a:t>Built for Databricks: documents and outputs live in your Unity Catalog volumes, and credentials come from a secret scope.</a:t>
+              <a:t>Built for Databricks: documents and results live in your own Unity Catalog storage, and keys live in a locked secret store.</a:t>
             </a:r>
           </a:p>
           <a:p>
@@ -6443,7 +6443,7 @@
                 </a:solidFill>
                 <a:latin typeface="Calibri"/>
               </a:rPr>
-              <a:t>The PHI posture is a design constraint — this demo runs only on anonymized material.</a:t>
+              <a:t>Keeping patient data safe is a design rule here — this demo only ever uses scrubbed documents.</a:t>
             </a:r>
           </a:p>
         </p:txBody>
@@ -6578,7 +6578,7 @@
                 </a:solidFill>
                 <a:latin typeface="Calibri"/>
               </a:rPr>
-              <a:t>Humans stay in control</a:t>
+              <a:t>People stay in charge</a:t>
             </a:r>
           </a:p>
         </p:txBody>
@@ -6623,7 +6623,7 @@
                 </a:solidFill>
                 <a:latin typeface="Calibri"/>
               </a:rPr>
-              <a:t>The agent never guesses. It flags an ambiguity, auto-confirms only what the data dictionary proves, and routes the rest to a reviewer.</a:t>
+              <a:t>The agent never guesses. Unclear things are set aside, proven ones are confirmed by the data, and the rest goes to a reviewer.</a:t>
             </a:r>
           </a:p>
           <a:p>
@@ -6645,7 +6645,7 @@
                 </a:solidFill>
                 <a:latin typeface="Calibri"/>
               </a:rPr>
-              <a:t>Adoption means reviewing a short list of open questions, not trusting a black box.</a:t>
+              <a:t>Adopting it means checking a short list of questions — not trusting a black box.</a:t>
             </a:r>
           </a:p>
         </p:txBody>
@@ -6780,7 +6780,7 @@
                 </a:solidFill>
                 <a:latin typeface="Calibri"/>
               </a:rPr>
-              <a:t>It compounds downstream</a:t>
+              <a:t>It pays off down the line</a:t>
             </a:r>
           </a:p>
         </p:txBody>
@@ -6825,7 +6825,7 @@
                 </a:solidFill>
                 <a:latin typeface="Calibri"/>
               </a:rPr>
-              <a:t>The contract this agent emits is what CodeGen consumes, which in turn feeds automated code review.</a:t>
+              <a:t>What this agent produces is exactly what CodeGen consumes, which then feeds Code Review.</a:t>
             </a:r>
           </a:p>
           <a:p>
@@ -6847,7 +6847,7 @@
                 </a:solidFill>
                 <a:latin typeface="Calibri"/>
               </a:rPr>
-              <a:t>Every FRD processed here shortens the whole chain: a governed path from requirement to running pipeline.</a:t>
+              <a:t>Every document processed here speeds up the whole chain, from requirement to running code.</a:t>
             </a:r>
           </a:p>
         </p:txBody>
@@ -7166,7 +7166,7 @@
                 </a:solidFill>
                 <a:latin typeface="Calibri"/>
               </a:rPr>
-              <a:t>Demoed locally today; the workspace shape is already defined in the repository.</a:t>
+              <a:t>Shown on a laptop today; the workspace version is already written into the code.</a:t>
             </a:r>
           </a:p>
         </p:txBody>
@@ -7345,7 +7345,7 @@
                 </a:solidFill>
                 <a:latin typeface="Calibri"/>
               </a:rPr>
-              <a:t>In place today</a:t>
+              <a:t>Ready today</a:t>
             </a:r>
           </a:p>
         </p:txBody>
@@ -7390,7 +7390,7 @@
                 </a:solidFill>
                 <a:latin typeface="Calibri"/>
               </a:rPr>
-              <a:t>An asset bundle defines a single job chaining all four stages with explicit dependencies, on serverless compute.</a:t>
+              <a:t>One Databricks job runs all four steps in order, on serverless compute — no machines for you to manage.</a:t>
             </a:r>
           </a:p>
           <a:p>
@@ -7412,7 +7412,7 @@
                 </a:solidFill>
                 <a:latin typeface="Calibri"/>
               </a:rPr>
-              <a:t>Unity Catalog volumes hold raw FRDs, reference workbooks and outputs — client documents never leave the workspace.</a:t>
+              <a:t>Documents and results live in Unity Catalog storage and never leave your workspace.</a:t>
             </a:r>
           </a:p>
           <a:p>
@@ -7434,7 +7434,7 @@
                 </a:solidFill>
                 <a:latin typeface="Calibri"/>
               </a:rPr>
-              <a:t>Anthropic credentials are read from a Databricks secret scope; no key exists in the repository.</a:t>
+              <a:t>The AI key sits in Databricks' locked secret store; there is no key anywhere in the code.</a:t>
             </a:r>
           </a:p>
           <a:p>
@@ -7456,7 +7456,7 @@
                 </a:solidFill>
                 <a:latin typeface="Calibri"/>
               </a:rPr>
-              <a:t>The review app is packaged as a Databricks App on the officially supported stack.</a:t>
+              <a:t>The review app is packaged the official Databricks way.</a:t>
             </a:r>
           </a:p>
           <a:p>
@@ -7478,7 +7478,7 @@
                 </a:solidFill>
                 <a:latin typeface="Calibri"/>
               </a:rPr>
-              <a:t>Orchestration retries are deliberately disabled — deterministic errors must surface, not be retried away.</a:t>
+              <a:t>If a step fails, the job stops and says so — it never quietly retries past a real problem.</a:t>
             </a:r>
           </a:p>
         </p:txBody>
@@ -7613,7 +7613,7 @@
                 </a:solidFill>
                 <a:latin typeface="Calibri"/>
               </a:rPr>
-              <a:t>The remaining port work — named, not hidden</a:t>
+              <a:t>Still to do — three plumbing items</a:t>
             </a:r>
           </a:p>
         </p:txBody>
@@ -7658,7 +7658,7 @@
                 </a:solidFill>
                 <a:latin typeface="Calibri"/>
               </a:rPr>
-              <a:t>The demo runs pipeline stages as local processes; in the workspace it triggers the bundle job and reads outputs from Unity Catalog.</a:t>
+              <a:t>Today the demo runs the steps on the laptop; the workspace version will press the Databricks job button instead.</a:t>
             </a:r>
           </a:p>
           <a:p>
@@ -7680,7 +7680,7 @@
                 </a:solidFill>
                 <a:latin typeface="Calibri"/>
               </a:rPr>
-              <a:t>The review app's API key must arrive through a Databricks Apps secret resource rather than a local environment file.</a:t>
+              <a:t>The app's AI key must come from Databricks' secret store rather than a local file.</a:t>
             </a:r>
           </a:p>
           <a:p>
@@ -7702,7 +7702,7 @@
                 </a:solidFill>
                 <a:latin typeface="Calibri"/>
               </a:rPr>
-              <a:t>Live progress streaming through the Apps proxy is expected to work but has not been exercised against a real workspace.</a:t>
+              <a:t>Live progress updates through Databricks' front door should work, but haven't been tried against a real workspace yet.</a:t>
             </a:r>
           </a:p>
           <a:p>
@@ -7724,7 +7724,7 @@
                 </a:solidFill>
                 <a:latin typeface="Calibri"/>
               </a:rPr>
-              <a:t>None of this touches the pipeline logic or the quality gates — it is plumbing between the same components.</a:t>
+              <a:t>None of this changes how the agent reads, checks or builds — it's plumbing between the same parts.</a:t>
             </a:r>
           </a:p>
         </p:txBody>
@@ -7822,7 +7822,7 @@
                 </a:solidFill>
                 <a:latin typeface="Calibri"/>
               </a:rPr>
-              <a:t>built for the workspace, currently demoed locally. The four stages you watch running are the same committed code a workspace job would run.</a:t>
+              <a:t>built for the workspace, shown on a laptop. What you watched running is the exact same code the workspace would run.</a:t>
             </a:r>
           </a:p>
         </p:txBody>
@@ -8096,7 +8096,7 @@
                 </a:solidFill>
                 <a:latin typeface="Calibri Light"/>
               </a:rPr>
-              <a:t>Where we are, and what we would do next</a:t>
+              <a:t>Where we are, and what's next</a:t>
             </a:r>
           </a:p>
         </p:txBody>
@@ -8141,7 +8141,7 @@
                 </a:solidFill>
                 <a:latin typeface="Calibri"/>
               </a:rPr>
-              <a:t>An honest read: the pipeline and its quality gates are proven; the surrounding integration is the work ahead.</a:t>
+              <a:t>The honest picture: the agent and its checks are proven; the wiring around them is the remaining work.</a:t>
             </a:r>
           </a:p>
         </p:txBody>
@@ -8274,7 +8274,7 @@
                 </a:solidFill>
                 <a:latin typeface="Calibri"/>
               </a:rPr>
-              <a:t>Extraction quality</a:t>
+              <a:t>Reading quality</a:t>
             </a:r>
           </a:p>
         </p:txBody>
@@ -8374,7 +8374,7 @@
                 </a:solidFill>
                 <a:latin typeface="Calibri"/>
               </a:rPr>
-              <a:t>Live end-to-end run: 94.1% fidelity, zero hallucinations, ~96% estimated first-pass keep rate.</a:t>
+              <a:t>Real run: 94.1% match, nothing made up, and about 96% of the output keepable exactly as-is.</a:t>
             </a:r>
           </a:p>
         </p:txBody>
@@ -8419,7 +8419,7 @@
                 </a:solidFill>
                 <a:latin typeface="Calibri"/>
               </a:rPr>
-              <a:t>Grounding &amp; gating</a:t>
+              <a:t>Checks &amp; asking</a:t>
             </a:r>
           </a:p>
         </p:txBody>
@@ -8519,7 +8519,7 @@
                 </a:solidFill>
                 <a:latin typeface="Calibri"/>
               </a:rPr>
-              <a:t>45/45 strict and 30/30 advisory checks, with human review wired end-to-end and unit-tested.</a:t>
+              <a:t>All 45 strict + 30 softer checks passed, and the ask-a-person flow works end to end.</a:t>
             </a:r>
           </a:p>
         </p:txBody>
@@ -8608,7 +8608,7 @@
                 </a:solidFill>
                 <a:latin typeface="Calibri"/>
               </a:rPr>
-              <a:t>Upstream hand-off</a:t>
+              <a:t>Hand-off from upstream</a:t>
             </a:r>
           </a:p>
         </p:txBody>
@@ -8708,7 +8708,7 @@
                 </a:solidFill>
                 <a:latin typeface="Calibri"/>
               </a:rPr>
-              <a:t>Versioned label contract shared byte-identically with the BRD→FRD agent, guarded by tests.</a:t>
+              <a:t>Both agents read one shared rule file, kept word-for-word identical by tests.</a:t>
             </a:r>
           </a:p>
         </p:txBody>
@@ -8753,7 +8753,7 @@
                 </a:solidFill>
                 <a:latin typeface="Calibri"/>
               </a:rPr>
-              <a:t>Workspace deployment</a:t>
+              <a:t>Databricks wiring</a:t>
             </a:r>
           </a:p>
         </p:txBody>
@@ -8853,7 +8853,7 @@
                 </a:solidFill>
                 <a:latin typeface="Calibri"/>
               </a:rPr>
-              <a:t>Trigger the bundle job from the app, source secrets via an Apps resource, exercise streaming.</a:t>
+              <a:t>Press the workspace job button from the app, move the key, and test live progress updates.</a:t>
             </a:r>
           </a:p>
         </p:txBody>
@@ -8942,7 +8942,7 @@
                 </a:solidFill>
                 <a:latin typeface="Calibri"/>
               </a:rPr>
-              <a:t>Downstream contract</a:t>
+              <a:t>The file for CodeGen</a:t>
             </a:r>
           </a:p>
         </p:txBody>
@@ -9042,7 +9042,7 @@
                 </a:solidFill>
                 <a:latin typeface="Calibri"/>
               </a:rPr>
-              <a:t>Emit the workbook-derived mapping contract CodeGen needs — the programme's biggest open gap.</a:t>
+              <a:t>Build the tool that makes the extra file CodeGen needs — the program's biggest missing piece.</a:t>
             </a:r>
           </a:p>
         </p:txBody>
@@ -9087,7 +9087,7 @@
                 </a:solidFill>
                 <a:latin typeface="Calibri"/>
               </a:rPr>
-              <a:t>Scale validation</a:t>
+              <a:t>Bigger documents</a:t>
             </a:r>
           </a:p>
         </p:txBody>
@@ -9187,7 +9187,7 @@
                 </a:solidFill>
                 <a:latin typeface="Calibri"/>
               </a:rPr>
-              <a:t>Run against a real, larger FRD to confirm the 75–90 feed headroom and tune chunking if needed.</a:t>
+              <a:t>Try a real, larger FRD to confirm the roughly 75–90 feed headroom holds up.</a:t>
             </a:r>
           </a:p>
         </p:txBody>
@@ -9329,7 +9329,7 @@
                 </a:solidFill>
                 <a:latin typeface="Calibri"/>
               </a:rPr>
-              <a:t>a real, non-sensitive FRD to validate at scale, and a workspace target for the deployment port.</a:t>
+              <a:t>one real (non-sensitive) FRD to test at full size, and a workspace to install into.</a:t>
             </a:r>
           </a:p>
         </p:txBody>
@@ -9713,7 +9713,7 @@
                 </a:solidFill>
                 <a:latin typeface="Calibri"/>
               </a:rPr>
-              <a:t>Happy to go back into the demo, open the workbook, or walk through any part of the pipeline in detail.</a:t>
+              <a:t>Happy to run the demo again, open the spreadsheet, or walk through any part in as much detail as you like.</a:t>
             </a:r>
           </a:p>
         </p:txBody>
@@ -9891,7 +9891,7 @@
                 </a:solidFill>
                 <a:latin typeface="Calibri"/>
               </a:rPr>
-              <a:t>—  How does it behave on an FRD far larger than the demo?</a:t>
+              <a:t>—  What about much bigger documents?</a:t>
             </a:r>
           </a:p>
           <a:p>
@@ -9913,7 +9913,7 @@
                 </a:solidFill>
                 <a:latin typeface="Calibri"/>
               </a:rPr>
-              <a:t>—  What happens when the document is genuinely ambiguous?</a:t>
+              <a:t>—  What happens when the document is unclear?</a:t>
             </a:r>
           </a:p>
           <a:p>
@@ -9935,7 +9935,7 @@
                 </a:solidFill>
                 <a:latin typeface="Calibri"/>
               </a:rPr>
-              <a:t>—  How do we know it hasn't invented a mapping?</a:t>
+              <a:t>—  How do we know it didn't make something up?</a:t>
             </a:r>
           </a:p>
           <a:p>
@@ -9957,7 +9957,7 @@
                 </a:solidFill>
                 <a:latin typeface="Calibri"/>
               </a:rPr>
-              <a:t>—  What does the review workload look like per document?</a:t>
+              <a:t>—  How much checking is left for a person to do?</a:t>
             </a:r>
           </a:p>
           <a:p>
@@ -9979,7 +9979,7 @@
                 </a:solidFill>
                 <a:latin typeface="Calibri"/>
               </a:rPr>
-              <a:t>—  How does this reach our workspace, and who holds the keys?</a:t>
+              <a:t>—  How does it get into our workspace — and who holds the keys?</a:t>
             </a:r>
           </a:p>
           <a:p>
@@ -10001,7 +10001,7 @@
                 </a:solidFill>
                 <a:latin typeface="Calibri"/>
               </a:rPr>
-              <a:t>—  What is the effort to close the CodeGen hand-off gap?</a:t>
+              <a:t>—  How big is the missing CodeGen piece?</a:t>
             </a:r>
           </a:p>
         </p:txBody>
@@ -10242,7 +10242,7 @@
                 </a:solidFill>
                 <a:latin typeface="Calibri"/>
               </a:rPr>
-              <a:t>About thirty minutes, with the live agent run in the middle and open Q&amp;A at the end.</a:t>
+              <a:t>About thirty minutes. The live run sits in the middle, and we finish with your questions.</a:t>
             </a:r>
           </a:p>
         </p:txBody>
@@ -10398,7 +10398,7 @@
                 </a:solidFill>
                 <a:latin typeface="Calibri"/>
               </a:rPr>
-              <a:t>The five-agent programme, and the hand-offs on either side of us.</a:t>
+              <a:t>It's one of five helpers that pass work to each other, one to the next.</a:t>
             </a:r>
           </a:p>
         </p:txBody>
@@ -10554,7 +10554,7 @@
                 </a:solidFill>
                 <a:latin typeface="Calibri"/>
               </a:rPr>
-              <a:t>Mapping work today: slow, inconsistent, and hard to audit after the fact.</a:t>
+              <a:t>Making mapping spreadsheets by hand is slow, uneven, and hard to check later.</a:t>
             </a:r>
           </a:p>
         </p:txBody>
@@ -10710,7 +10710,7 @@
                 </a:solidFill>
                 <a:latin typeface="Calibri"/>
               </a:rPr>
-              <a:t>Four stages, and the split between what the model does and what code does.</a:t>
+              <a:t>Four simple steps — and what the AI does versus what plain code does.</a:t>
             </a:r>
           </a:p>
         </p:txBody>
@@ -10844,7 +10844,7 @@
                 </a:solidFill>
                 <a:latin typeface="Calibri"/>
               </a:rPr>
-              <a:t>Trust architecture</a:t>
+              <a:t>Why you can trust it</a:t>
             </a:r>
           </a:p>
           <a:p>
@@ -10866,7 +10866,7 @@
                 </a:solidFill>
                 <a:latin typeface="Calibri"/>
               </a:rPr>
-              <a:t>Verbatim grounding audit, ambiguity gating, human-in-the-loop review.</a:t>
+              <a:t>It shows its work on every value, and it asks a person when it isn't sure.</a:t>
             </a:r>
           </a:p>
         </p:txBody>
@@ -11022,7 +11022,7 @@
                 </a:solidFill>
                 <a:latin typeface="Calibri"/>
               </a:rPr>
-              <a:t>An FRD in, an STTM workbook out — run on the spot, with an offline backup.</a:t>
+              <a:t>A document goes in, a spreadsheet comes out — run right here, with an offline backup.</a:t>
             </a:r>
           </a:p>
         </p:txBody>
@@ -11178,7 +11178,7 @@
                 </a:solidFill>
                 <a:latin typeface="Calibri"/>
               </a:rPr>
-              <a:t>Measured results from the live run, and what they mean for delivery.</a:t>
+              <a:t>Real measured results, and what they mean for your teams.</a:t>
             </a:r>
           </a:p>
         </p:txBody>
@@ -11334,7 +11334,7 @@
                 </a:solidFill>
                 <a:latin typeface="Calibri"/>
               </a:rPr>
-              <a:t>What is proven, what is still port work, and your questions.</a:t>
+              <a:t>What's done, what's next, and your questions.</a:t>
             </a:r>
           </a:p>
         </p:txBody>
@@ -11652,7 +11652,7 @@
                 </a:solidFill>
                 <a:latin typeface="Calibri Light"/>
               </a:rPr>
-              <a:t>Second agent in a five-agent programme</a:t>
+              <a:t>The second of five helpers</a:t>
             </a:r>
           </a:p>
         </p:txBody>
@@ -11697,7 +11697,7 @@
                 </a:solidFill>
                 <a:latin typeface="Calibri"/>
               </a:rPr>
-              <a:t>Each agent consumes the previous one's approved output through a versioned, machine-readable contract.</a:t>
+              <a:t>Each helper hands its finished work to the next one as a file a computer can read — not as an email attachment.</a:t>
             </a:r>
           </a:p>
         </p:txBody>
@@ -11854,7 +11854,7 @@
                 </a:solidFill>
                 <a:latin typeface="Calibri"/>
               </a:rPr>
-              <a:t>Business requirements</a:t>
+              <a:t>Turns business wishes</a:t>
             </a:r>
           </a:p>
           <a:p>
@@ -11876,7 +11876,7 @@
                 </a:solidFill>
                 <a:latin typeface="Calibri"/>
               </a:rPr>
-              <a:t>to functional spec</a:t>
+              <a:t>into a working spec</a:t>
             </a:r>
           </a:p>
         </p:txBody>
@@ -12053,7 +12053,7 @@
                 </a:solidFill>
                 <a:latin typeface="Calibri"/>
               </a:rPr>
-              <a:t>Mapping workbook</a:t>
+              <a:t>Makes the mapping</a:t>
             </a:r>
           </a:p>
           <a:p>
@@ -12075,7 +12075,7 @@
                 </a:solidFill>
                 <a:latin typeface="Calibri"/>
               </a:rPr>
-              <a:t>+ feed contract</a:t>
+              <a:t>spreadsheet + contract</a:t>
             </a:r>
           </a:p>
         </p:txBody>
@@ -12232,7 +12232,7 @@
                 </a:solidFill>
                 <a:latin typeface="Calibri"/>
               </a:rPr>
-              <a:t>Pipeline code from</a:t>
+              <a:t>Writes the pipeline</a:t>
             </a:r>
           </a:p>
           <a:p>
@@ -12254,7 +12254,7 @@
                 </a:solidFill>
                 <a:latin typeface="Calibri"/>
               </a:rPr>
-              <a:t>the mapping contract</a:t>
+              <a:t>code</a:t>
             </a:r>
           </a:p>
         </p:txBody>
@@ -12411,7 +12411,7 @@
                 </a:solidFill>
                 <a:latin typeface="Calibri"/>
               </a:rPr>
-              <a:t>Automated review of</a:t>
+              <a:t>Checks the generated</a:t>
             </a:r>
           </a:p>
           <a:p>
@@ -12433,7 +12433,7 @@
                 </a:solidFill>
                 <a:latin typeface="Calibri"/>
               </a:rPr>
-              <a:t>the generated code</a:t>
+              <a:t>code</a:t>
             </a:r>
           </a:p>
         </p:txBody>
@@ -12478,7 +12478,7 @@
                 </a:solidFill>
                 <a:latin typeface="Calibri"/>
               </a:rPr>
-              <a:t>SQL Optimization runs as a standalone fifth agent alongside this chain.</a:t>
+              <a:t>SQL Optimization runs as a standalone fifth helper alongside this chain.</a:t>
             </a:r>
           </a:p>
         </p:txBody>
@@ -12613,7 +12613,7 @@
                 </a:solidFill>
                 <a:latin typeface="Calibri"/>
               </a:rPr>
-              <a:t>Upstream — solved, and versioned</a:t>
+              <a:t>Upstream — already solved</a:t>
             </a:r>
           </a:p>
         </p:txBody>
@@ -12658,7 +12658,7 @@
                 </a:solidFill>
                 <a:latin typeface="Calibri"/>
               </a:rPr>
-              <a:t>This agent and the BRD→FRD agent share one versioned label contract, committed byte-identically to both repos.</a:t>
+              <a:t>This agent and the BRD→FRD agent read the same shared rule file, kept word-for-word identical in both code bases.</a:t>
             </a:r>
           </a:p>
           <a:p>
@@ -12680,7 +12680,7 @@
                 </a:solidFill>
                 <a:latin typeface="Calibri"/>
               </a:rPr>
-              <a:t>Section headings, requirement-ID families and placeholders are read from that file, never hardcoded.</a:t>
+              <a:t>Headings, ID formats and placeholders all come from that file — never typed into the code.</a:t>
             </a:r>
           </a:p>
           <a:p>
@@ -12702,7 +12702,7 @@
                 </a:solidFill>
                 <a:latin typeface="Calibri"/>
               </a:rPr>
-              <a:t>A round-trip test suite fails the build if the two copies drift apart.</a:t>
+              <a:t>If the two copies ever differ, the tests fail the build.</a:t>
             </a:r>
           </a:p>
         </p:txBody>
@@ -12837,7 +12837,7 @@
                 </a:solidFill>
                 <a:latin typeface="Calibri"/>
               </a:rPr>
-              <a:t>Downstream — the gap we're flagging</a:t>
+              <a:t>Downstream — one missing piece</a:t>
             </a:r>
           </a:p>
         </p:txBody>
@@ -12882,7 +12882,7 @@
                 </a:solidFill>
                 <a:latin typeface="Calibri"/>
               </a:rPr>
-              <a:t>This agent emits the FRD feed contract that CodeGen consumes. That half works today.</a:t>
+              <a:t>This agent already makes the file CodeGen reads. That part works today.</a:t>
             </a:r>
           </a:p>
           <a:p>
@@ -12904,7 +12904,7 @@
                 </a:solidFill>
                 <a:latin typeface="Calibri"/>
               </a:rPr>
-              <a:t>CodeGen also needs a workbook-derived mapping contract, and no committed tool produces it yet.</a:t>
+              <a:t>But CodeGen also needs a second file made from the spreadsheet — and no tool makes it yet.</a:t>
             </a:r>
           </a:p>
           <a:p>
@@ -12926,7 +12926,7 @@
                 </a:solidFill>
                 <a:latin typeface="Calibri"/>
               </a:rPr>
-              <a:t>Closing this is the highest-value next step for the programme — and we are not hiding it.</a:t>
+              <a:t>Building that tool is the most useful next step. We're saying so up front.</a:t>
             </a:r>
           </a:p>
         </p:txBody>
@@ -13200,7 +13200,7 @@
                 </a:solidFill>
                 <a:latin typeface="Calibri Light"/>
               </a:rPr>
-              <a:t>Source-to-target mapping is the bottleneck</a:t>
+              <a:t>Making these spreadsheets by hand is the bottleneck</a:t>
             </a:r>
           </a:p>
         </p:txBody>
@@ -13245,7 +13245,7 @@
                 </a:solidFill>
                 <a:latin typeface="Calibri"/>
               </a:rPr>
-              <a:t>The FRD is approved and the target model is known — yet the mapping workbook is still assembled by hand, one cell at a time.</a:t>
+              <a:t>The document is approved and the targets are known — yet someone still types the whole spreadsheet, one cell at a time.</a:t>
             </a:r>
           </a:p>
         </p:txBody>
@@ -13400,7 +13400,7 @@
                 </a:solidFill>
                 <a:latin typeface="Calibri"/>
               </a:rPr>
-              <a:t>An analyst reads the whole FRD, cross-references the data dictionary, and hand-builds every row of the workbook. Days of effort per document.</a:t>
+              <a:t>A person reads the whole FRD, cross-checks the data dictionary, and types every row of the spreadsheet by hand. It takes days.</a:t>
             </a:r>
           </a:p>
         </p:txBody>
@@ -13489,7 +13489,7 @@
                 </a:solidFill>
                 <a:latin typeface="Calibri"/>
               </a:rPr>
-              <a:t>Inconsistent</a:t>
+              <a:t>Uneven</a:t>
             </a:r>
           </a:p>
           <a:p>
@@ -13511,7 +13511,7 @@
                 </a:solidFill>
                 <a:latin typeface="Calibri"/>
               </a:rPr>
-              <a:t>Two analysts reading the same FRD produce two different workbooks. Naming, load strategies and rule attribution drift between feeds and teams.</a:t>
+              <a:t>Two people reading the same document make two different spreadsheets. Names and rules drift between feeds and teams.</a:t>
             </a:r>
           </a:p>
         </p:txBody>
@@ -13600,7 +13600,7 @@
                 </a:solidFill>
                 <a:latin typeface="Calibri"/>
               </a:rPr>
-              <a:t>Hard to audit</a:t>
+              <a:t>Hard to check later</a:t>
             </a:r>
           </a:p>
           <a:p>
@@ -13622,7 +13622,7 @@
                 </a:solidFill>
                 <a:latin typeface="Calibri"/>
               </a:rPr>
-              <a:t>Six months later, nobody can say which sentence in the FRD justified a given mapping cell. Reconstructing that is manual archaeology.</a:t>
+              <a:t>Months later, nobody remembers which sentence in the document a spreadsheet cell came from. Finding out again is digging.</a:t>
             </a:r>
           </a:p>
         </p:txBody>
@@ -13711,7 +13711,7 @@
                 </a:solidFill>
                 <a:latin typeface="Calibri"/>
               </a:rPr>
-              <a:t>A blocker for everything downstream</a:t>
+              <a:t>It holds everything up</a:t>
             </a:r>
           </a:p>
           <a:p>
@@ -13733,7 +13733,7 @@
                 </a:solidFill>
                 <a:latin typeface="Calibri"/>
               </a:rPr>
-              <a:t>Code generation, testing and review all wait on the workbook. The slowest manual step sets the pace for the whole delivery chain.</a:t>
+              <a:t>Code, tests and reviews all wait for this spreadsheet. The slowest manual step sets the pace for everything after it.</a:t>
             </a:r>
           </a:p>
         </p:txBody>
@@ -13866,7 +13866,7 @@
                 </a:solidFill>
                 <a:latin typeface="Calibri"/>
               </a:rPr>
-              <a:t>WHAT WE ARE AUTOMATING</a:t>
+              <a:t>WHAT WE'RE AUTOMATING</a:t>
             </a:r>
           </a:p>
           <a:p>
@@ -13889,8 +13889,8 @@
                 <a:latin typeface="Calibri Light"/>
               </a:rPr>
               <a:t>The reading and the
-transcription — not
-the judgement.</a:t>
+typing — not the
+thinking.</a:t>
             </a:r>
           </a:p>
           <a:p>
@@ -13912,7 +13912,7 @@
                 </a:solidFill>
                 <a:latin typeface="Calibri"/>
               </a:rPr>
-              <a:t>The agent extracts what the document actually says, checks every value back against the source text, and builds the workbook.</a:t>
+              <a:t>The agent copies out what the document actually says, checks every value back against the text, and fills in the spreadsheet.</a:t>
             </a:r>
           </a:p>
           <a:p>
@@ -13934,7 +13934,7 @@
                 </a:solidFill>
                 <a:latin typeface="Calibri"/>
               </a:rPr>
-              <a:t>Where the document is genuinely ambiguous, it stops and asks a human rather than guessing.</a:t>
+              <a:t>When the document isn't clear, it stops and asks a person instead of guessing.</a:t>
             </a:r>
           </a:p>
         </p:txBody>
@@ -14208,7 +14208,7 @@
                 </a:solidFill>
                 <a:latin typeface="Calibri Light"/>
               </a:rPr>
-              <a:t>Four stages, one job each</a:t>
+              <a:t>Four steps, one job each</a:t>
             </a:r>
           </a:p>
         </p:txBody>
@@ -14253,7 +14253,7 @@
                 </a:solidFill>
                 <a:latin typeface="Calibri"/>
               </a:rPr>
-              <a:t>Runs as a Databricks job on serverless compute, or as four plain scripts — the same committed code either way.</a:t>
+              <a:t>Runs on Databricks or on a plain laptop — the exact same code either way.</a:t>
             </a:r>
           </a:p>
         </p:txBody>
@@ -14476,7 +14476,7 @@
                 </a:solidFill>
                 <a:latin typeface="Calibri"/>
               </a:rPr>
-              <a:t>FRD .docx → markdown</a:t>
+              <a:t>read the document</a:t>
             </a:r>
           </a:p>
         </p:txBody>
@@ -14521,7 +14521,7 @@
                 </a:solidFill>
                 <a:latin typeface="Calibri"/>
               </a:rPr>
-              <a:t>·  Parses the approved FRD</a:t>
+              <a:t>·  Opens the FRD file</a:t>
             </a:r>
           </a:p>
           <a:p>
@@ -14533,7 +14533,7 @@
                 <a:spcPts val="0"/>
               </a:spcBef>
               <a:spcAft>
-                <a:spcPts val="0"/>
+                <a:spcPts val="900"/>
               </a:spcAft>
             </a:pPr>
             <a:r>
@@ -14543,7 +14543,7 @@
                 </a:solidFill>
                 <a:latin typeface="Calibri"/>
               </a:rPr>
-              <a:t>·  Section labels from the</a:t>
+              <a:t>·  Turns it into plain text</a:t>
             </a:r>
           </a:p>
           <a:p>
@@ -14565,29 +14565,7 @@
                 </a:solidFill>
                 <a:latin typeface="Calibri"/>
               </a:rPr>
-              <a:t>    shared contract</a:t>
-            </a:r>
-          </a:p>
-          <a:p>
-            <a:pPr algn="l">
-              <a:lnSpc>
-                <a:spcPct val="110000"/>
-              </a:lnSpc>
-              <a:spcBef>
-                <a:spcPts val="0"/>
-              </a:spcBef>
-              <a:spcAft>
-                <a:spcPts val="900"/>
-              </a:spcAft>
-            </a:pPr>
-            <a:r>
-              <a:rPr sz="1150" b="0" i="0">
-                <a:solidFill>
-                  <a:srgbClr val="3A4A5C"/>
-                </a:solidFill>
-                <a:latin typeface="Calibri"/>
-              </a:rPr>
-              <a:t>·  Lands in a Delta table</a:t>
+              <a:t>·  Saves it in a table</a:t>
             </a:r>
           </a:p>
         </p:txBody>
@@ -14810,7 +14788,7 @@
                 </a:solidFill>
                 <a:latin typeface="Calibri"/>
               </a:rPr>
-              <a:t>the one model call</a:t>
+              <a:t>the one AI step</a:t>
             </a:r>
           </a:p>
         </p:txBody>
@@ -14845,7 +14823,7 @@
                 <a:spcPts val="0"/>
               </a:spcBef>
               <a:spcAft>
-                <a:spcPts val="0"/>
+                <a:spcPts val="900"/>
               </a:spcAft>
             </a:pPr>
             <a:r>
@@ -14855,7 +14833,7 @@
                 </a:solidFill>
                 <a:latin typeface="Calibri"/>
               </a:rPr>
-              <a:t>·  Claude reads the FRD</a:t>
+              <a:t>·  Claude reads the text</a:t>
             </a:r>
           </a:p>
           <a:p>
@@ -14877,7 +14855,7 @@
                 </a:solidFill>
                 <a:latin typeface="Calibri"/>
               </a:rPr>
-              <a:t>    against a strict schema</a:t>
+              <a:t>·  Fills in a strict form</a:t>
             </a:r>
           </a:p>
           <a:p>
@@ -14899,7 +14877,7 @@
                 </a:solidFill>
                 <a:latin typeface="Calibri"/>
               </a:rPr>
-              <a:t>·  Streaming, validated</a:t>
+              <a:t>·  If it can't, it stops</a:t>
             </a:r>
           </a:p>
           <a:p>
@@ -14921,51 +14899,7 @@
                 </a:solidFill>
                 <a:latin typeface="Calibri"/>
               </a:rPr>
-              <a:t>    client-side</a:t>
-            </a:r>
-          </a:p>
-          <a:p>
-            <a:pPr algn="l">
-              <a:lnSpc>
-                <a:spcPct val="110000"/>
-              </a:lnSpc>
-              <a:spcBef>
-                <a:spcPts val="0"/>
-              </a:spcBef>
-              <a:spcAft>
-                <a:spcPts val="0"/>
-              </a:spcAft>
-            </a:pPr>
-            <a:r>
-              <a:rPr sz="1150" b="0" i="0">
-                <a:solidFill>
-                  <a:srgbClr val="3A4A5C"/>
-                </a:solidFill>
-                <a:latin typeface="Calibri"/>
-              </a:rPr>
-              <a:t>·  Fails loudly, never</a:t>
-            </a:r>
-          </a:p>
-          <a:p>
-            <a:pPr algn="l">
-              <a:lnSpc>
-                <a:spcPct val="110000"/>
-              </a:lnSpc>
-              <a:spcBef>
-                <a:spcPts val="0"/>
-              </a:spcBef>
-              <a:spcAft>
-                <a:spcPts val="900"/>
-              </a:spcAft>
-            </a:pPr>
-            <a:r>
-              <a:rPr sz="1150" b="0" i="0">
-                <a:solidFill>
-                  <a:srgbClr val="3A4A5C"/>
-                </a:solidFill>
-                <a:latin typeface="Calibri"/>
-              </a:rPr>
-              <a:t>    silently retries</a:t>
+              <a:t>    and says so</a:t>
             </a:r>
           </a:p>
         </p:txBody>
@@ -15188,7 +15122,7 @@
                 </a:solidFill>
                 <a:latin typeface="Calibri"/>
               </a:rPr>
-              <a:t>validate · audit · gate</a:t>
+              <a:t>check everything</a:t>
             </a:r>
           </a:p>
         </p:txBody>
@@ -15233,7 +15167,7 @@
                 </a:solidFill>
                 <a:latin typeface="Calibri"/>
               </a:rPr>
-              <a:t>·  Schema validation and</a:t>
+              <a:t>·  Checks the form is</a:t>
             </a:r>
           </a:p>
           <a:p>
@@ -15255,7 +15189,7 @@
                 </a:solidFill>
                 <a:latin typeface="Calibri"/>
               </a:rPr>
-              <a:t>    regex enrichment</a:t>
+              <a:t>    filled in right</a:t>
             </a:r>
           </a:p>
           <a:p>
@@ -15267,6 +15201,28 @@
                 <a:spcPts val="0"/>
               </a:spcBef>
               <a:spcAft>
+                <a:spcPts val="0"/>
+              </a:spcAft>
+            </a:pPr>
+            <a:r>
+              <a:rPr sz="1150" b="0" i="0">
+                <a:solidFill>
+                  <a:srgbClr val="3A4A5C"/>
+                </a:solidFill>
+                <a:latin typeface="Calibri"/>
+              </a:rPr>
+              <a:t>·  Checks each value is</a:t>
+            </a:r>
+          </a:p>
+          <a:p>
+            <a:pPr algn="l">
+              <a:lnSpc>
+                <a:spcPct val="110000"/>
+              </a:lnSpc>
+              <a:spcBef>
+                <a:spcPts val="0"/>
+              </a:spcBef>
+              <a:spcAft>
                 <a:spcPts val="900"/>
               </a:spcAft>
             </a:pPr>
@@ -15277,7 +15233,7 @@
                 </a:solidFill>
                 <a:latin typeface="Calibri"/>
               </a:rPr>
-              <a:t>·  Verbatim grounding audit</a:t>
+              <a:t>    really in the document</a:t>
             </a:r>
           </a:p>
           <a:p>
@@ -15289,7 +15245,7 @@
                 <a:spcPts val="0"/>
               </a:spcBef>
               <a:spcAft>
-                <a:spcPts val="0"/>
+                <a:spcPts val="900"/>
               </a:spcAft>
             </a:pPr>
             <a:r>
@@ -15299,29 +15255,7 @@
                 </a:solidFill>
                 <a:latin typeface="Calibri"/>
               </a:rPr>
-              <a:t>·  Ambiguities gated</a:t>
-            </a:r>
-          </a:p>
-          <a:p>
-            <a:pPr algn="l">
-              <a:lnSpc>
-                <a:spcPct val="110000"/>
-              </a:lnSpc>
-              <a:spcBef>
-                <a:spcPts val="0"/>
-              </a:spcBef>
-              <a:spcAft>
-                <a:spcPts val="900"/>
-              </a:spcAft>
-            </a:pPr>
-            <a:r>
-              <a:rPr sz="1150" b="0" i="0">
-                <a:solidFill>
-                  <a:srgbClr val="3A4A5C"/>
-                </a:solidFill>
-                <a:latin typeface="Calibri"/>
-              </a:rPr>
-              <a:t>    for review</a:t>
+              <a:t>·  Sets unclear things aside</a:t>
             </a:r>
           </a:p>
         </p:txBody>
@@ -15544,7 +15478,7 @@
                 </a:solidFill>
                 <a:latin typeface="Calibri"/>
               </a:rPr>
-              <a:t>the deliverable</a:t>
+              <a:t>make the spreadsheet</a:t>
             </a:r>
           </a:p>
         </p:txBody>
@@ -15589,7 +15523,7 @@
                 </a:solidFill>
                 <a:latin typeface="Calibri"/>
               </a:rPr>
-              <a:t>·  Data-dictionary</a:t>
+              <a:t>·  Double-checks with the</a:t>
             </a:r>
           </a:p>
           <a:p>
@@ -15611,7 +15545,7 @@
                 </a:solidFill>
                 <a:latin typeface="Calibri"/>
               </a:rPr>
-              <a:t>    cross-check</a:t>
+              <a:t>    data dictionary</a:t>
             </a:r>
           </a:p>
           <a:p>
@@ -15633,7 +15567,7 @@
                 </a:solidFill>
                 <a:latin typeface="Calibri"/>
               </a:rPr>
-              <a:t>·  Renders the client</a:t>
+              <a:t>·  Builds the STTM</a:t>
             </a:r>
           </a:p>
           <a:p>
@@ -15655,7 +15589,7 @@
                 </a:solidFill>
                 <a:latin typeface="Calibri"/>
               </a:rPr>
-              <a:t>    STTM workbook</a:t>
+              <a:t>    spreadsheet</a:t>
             </a:r>
           </a:p>
           <a:p>
@@ -15677,7 +15611,7 @@
                 </a:solidFill>
                 <a:latin typeface="Calibri"/>
               </a:rPr>
-              <a:t>·  Cell-level eval vs.</a:t>
+              <a:t>·  Scores it against the</a:t>
             </a:r>
           </a:p>
           <a:p>
@@ -15699,7 +15633,7 @@
                 </a:solidFill>
                 <a:latin typeface="Calibri"/>
               </a:rPr>
-              <a:t>    reference</a:t>
+              <a:t>    answer sheet</a:t>
             </a:r>
           </a:p>
         </p:txBody>
@@ -15834,7 +15768,7 @@
                 </a:solidFill>
                 <a:latin typeface="Calibri"/>
               </a:rPr>
-              <a:t>Deliberate division of labour</a:t>
+              <a:t>Who does what</a:t>
             </a:r>
           </a:p>
           <a:p>
@@ -15856,7 +15790,7 @@
                 </a:solidFill>
                 <a:latin typeface="Calibri"/>
               </a:rPr>
-              <a:t>The model reads prose and scattered requirement tables. </a:t>
+              <a:t>The AI only reads the document and copies things out. </a:t>
             </a:r>
             <a:r>
               <a:rPr sz="1250" b="1">
@@ -15865,7 +15799,7 @@
                 </a:solidFill>
                 <a:latin typeface="Calibri"/>
               </a:rPr>
-              <a:t>Deterministic code owns everything else</a:t>
+              <a:t>Plain, predictable code does everything else</a:t>
             </a:r>
             <a:r>
               <a:rPr sz="1250" b="0">
@@ -15874,7 +15808,7 @@
                 </a:solidFill>
                 <a:latin typeface="Calibri"/>
               </a:rPr>
-              <a:t> — validation, regex-able facts, grounding checks, rule attribution and the rendering of the workbook itself.</a:t>
+              <a:t> — the checking, the deciding, and the building of the spreadsheet. The AI never writes a cell the code can't back up.</a:t>
             </a:r>
           </a:p>
         </p:txBody>
@@ -16103,7 +16037,7 @@
                 </a:solidFill>
                 <a:latin typeface="Calibri"/>
               </a:rPr>
-              <a:t>TRUST ARCHITECTURE</a:t>
+              <a:t>WHY TRUST IT</a:t>
             </a:r>
           </a:p>
         </p:txBody>
@@ -16148,7 +16082,7 @@
                 </a:solidFill>
                 <a:latin typeface="Calibri Light"/>
               </a:rPr>
-              <a:t>Why you can put this in front of an auditor</a:t>
+              <a:t>Why you can trust what it makes</a:t>
             </a:r>
           </a:p>
         </p:txBody>
@@ -16193,7 +16127,7 @@
                 </a:solidFill>
                 <a:latin typeface="Calibri"/>
               </a:rPr>
-              <a:t>Three mechanisms — all deterministic, all running on every single document.</a:t>
+              <a:t>Three simple habits — followed by plain code, on every single document.</a:t>
             </a:r>
           </a:p>
         </p:txBody>
@@ -16417,7 +16351,7 @@
                 </a:solidFill>
                 <a:latin typeface="Calibri"/>
               </a:rPr>
-              <a:t>Verbatim grounding audit</a:t>
+              <a:t>It shows its work</a:t>
             </a:r>
           </a:p>
         </p:txBody>
@@ -16462,7 +16396,7 @@
                 </a:solidFill>
                 <a:latin typeface="Calibri"/>
               </a:rPr>
-              <a:t>Every strict field the model produces must appear verbatim in the source document; prose fields are checked by token overlap.</a:t>
+              <a:t>Every important value it writes must appear word-for-word in the source document. Looser text is checked for close match.</a:t>
             </a:r>
           </a:p>
           <a:p>
@@ -16484,7 +16418,7 @@
                 </a:solidFill>
                 <a:latin typeface="Calibri"/>
               </a:rPr>
-              <a:t>On the live run: 45 of 45 strict and 30 of 30 advisory checks passed.</a:t>
+              <a:t>On the live run: all 45 strict checks and all 30 softer checks passed.</a:t>
             </a:r>
           </a:p>
           <a:p>
@@ -16506,7 +16440,7 @@
                 </a:solidFill>
                 <a:latin typeface="Calibri"/>
               </a:rPr>
-              <a:t>This is the quality gate. It is never relaxed to make a run pass.</a:t>
+              <a:t>This rule is never loosened just to make a run pass.</a:t>
             </a:r>
           </a:p>
         </p:txBody>
@@ -16686,7 +16620,7 @@
                 </a:solidFill>
                 <a:latin typeface="Calibri"/>
               </a:rPr>
-              <a:t>Ambiguity gating</a:t>
+              <a:t>When unsure, it asks</a:t>
             </a:r>
           </a:p>
         </p:txBody>
@@ -16731,7 +16665,7 @@
                 </a:solidFill>
                 <a:latin typeface="Calibri"/>
               </a:rPr>
-              <a:t>Where the FRD does not say which feed a rule belongs to, the agent records a gated ambiguity instead of choosing.</a:t>
+              <a:t>If the document doesn't say which feed a rule belongs to, the agent doesn't pick one — it sets the question aside.</a:t>
             </a:r>
           </a:p>
           <a:p>
@@ -16753,7 +16687,7 @@
                 </a:solidFill>
                 <a:latin typeface="Calibri"/>
               </a:rPr>
-              <a:t>A deterministic data-dictionary cross-check then auto-confirms whatever the data itself proves.</a:t>
+              <a:t>A plain code check against the data dictionary then confirms whatever the data itself can prove.</a:t>
             </a:r>
           </a:p>
           <a:p>
@@ -16775,7 +16709,7 @@
                 </a:solidFill>
                 <a:latin typeface="Calibri"/>
               </a:rPr>
-              <a:t>Anything it cannot prove waits for a person.</a:t>
+              <a:t>Whatever it can't prove waits for a person.</a:t>
             </a:r>
           </a:p>
         </p:txBody>
@@ -16955,7 +16889,7 @@
                 </a:solidFill>
                 <a:latin typeface="Calibri"/>
               </a:rPr>
-              <a:t>Human-in-the-loop review</a:t>
+              <a:t>A person has the last word</a:t>
             </a:r>
           </a:p>
         </p:txBody>
@@ -17000,7 +16934,7 @@
                 </a:solidFill>
                 <a:latin typeface="Calibri"/>
               </a:rPr>
-              <a:t>A review app shows each gated item with its candidates and source context.</a:t>
+              <a:t>A small review app lists each open question with its options and the text it came from.</a:t>
             </a:r>
           </a:p>
           <a:p>
@@ -17022,7 +16956,7 @@
                 </a:solidFill>
                 <a:latin typeface="Calibri"/>
               </a:rPr>
-              <a:t>The reviewer picks or overrides, and that decision is written into the contract — never re-decided by the heuristic.</a:t>
+              <a:t>The reviewer picks an answer; that answer is saved and the agent never overrides it.</a:t>
             </a:r>
           </a:p>
           <a:p>
@@ -17044,7 +16978,7 @@
                 </a:solidFill>
                 <a:latin typeface="Calibri"/>
               </a:rPr>
-              <a:t>Your analysts stay the decision-makers.</a:t>
+              <a:t>Your analysts stay in charge.</a:t>
             </a:r>
           </a:p>
         </p:txBody>
@@ -17133,7 +17067,7 @@
                 </a:solidFill>
                 <a:latin typeface="Calibri"/>
               </a:rPr>
-              <a:t>THE RESULT, IN ONE SENTENCE</a:t>
+              <a:t>IN ONE SENTENCE</a:t>
             </a:r>
           </a:p>
           <a:p>
@@ -17155,7 +17089,7 @@
                 </a:solidFill>
                 <a:latin typeface="Calibri"/>
               </a:rPr>
-              <a:t>Every value in the workbook is traced back to the sentence that justified it, and nothing the agent is unsure of reaches the workbook unreviewed.</a:t>
+              <a:t>Every cell in the spreadsheet can be traced back to the sentence it came from — and nothing the agent is unsure about goes out without a person looking first.</a:t>
             </a:r>
           </a:p>
         </p:txBody>
@@ -17495,8 +17429,8 @@
                 </a:solidFill>
                 <a:latin typeface="Calibri"/>
               </a:rPr>
-              <a:t>One approved FRD in. One STTM workbook out.
-Run live, on this laptop, in about thirty seconds.</a:t>
+              <a:t>One FRD document goes in. One STTM spreadsheet comes out.
+Live, on this laptop, in about thirty seconds.</a:t>
             </a:r>
           </a:p>
         </p:txBody>
@@ -17607,7 +17541,7 @@
                 </a:solidFill>
                 <a:latin typeface="Calibri"/>
               </a:rPr>
-              <a:t>docx → markdown</a:t>
+              <a:t>read the document</a:t>
             </a:r>
           </a:p>
         </p:txBody>
@@ -17762,7 +17696,7 @@
                 </a:solidFill>
                 <a:latin typeface="Calibri"/>
               </a:rPr>
-              <a:t>one live model call</a:t>
+              <a:t>the one AI step</a:t>
             </a:r>
           </a:p>
         </p:txBody>
@@ -17917,7 +17851,7 @@
                 </a:solidFill>
                 <a:latin typeface="Calibri"/>
               </a:rPr>
-              <a:t>validate · audit · gate</a:t>
+              <a:t>check everything</a:t>
             </a:r>
           </a:p>
         </p:txBody>
@@ -18072,7 +18006,7 @@
                 </a:solidFill>
                 <a:latin typeface="Calibri"/>
               </a:rPr>
-              <a:t>workbook + score</a:t>
+              <a:t>spreadsheet + score</a:t>
             </a:r>
           </a:p>
         </p:txBody>
@@ -18139,7 +18073,7 @@
                 </a:solidFill>
                 <a:latin typeface="Calibri"/>
               </a:rPr>
-              <a:t>Every demo run is saved. If the network misbehaves we replay a recorded run — the same screens, zero API calls, fully offline.</a:t>
+              <a:t>Every demo run is saved. If the internet acts up, we replay a saved run — the same screens, no internet needed at all.</a:t>
             </a:r>
           </a:p>
         </p:txBody>
@@ -18380,7 +18314,7 @@
                 </a:solidFill>
                 <a:latin typeface="Calibri"/>
               </a:rPr>
-              <a:t>Five moments on the results screen — each one is a claim we can defend.</a:t>
+              <a:t>Five moments on the results screen — each one backs up something we've claimed today.</a:t>
             </a:r>
           </a:p>
         </p:txBody>
@@ -18514,7 +18448,7 @@
                 </a:solidFill>
                 <a:latin typeface="Calibri"/>
               </a:rPr>
-              <a:t>Extraction summary</a:t>
+              <a:t>What it found</a:t>
             </a:r>
           </a:p>
           <a:p>
@@ -18536,7 +18470,7 @@
                 </a:solidFill>
                 <a:latin typeface="Calibri"/>
               </a:rPr>
-              <a:t>Three feeds, their file patterns, target tables and rules. All of it came out of the document — nothing is templated.</a:t>
+              <a:t>Three data feeds, their file names, target tables and rules. All of it read out of the document — none of it pre-written.</a:t>
             </a:r>
           </a:p>
         </p:txBody>
@@ -18648,7 +18582,7 @@
                 </a:solidFill>
                 <a:latin typeface="Calibri"/>
               </a:rPr>
-              <a:t>"N detected, M auto-confirmed against the data dictionary, K awaiting human review." The human-in-the-loop centrepiece.</a:t>
+              <a:t>"N unclear things found, M proven by the data, K waiting for a person." This is the ask-a-human part, live on screen.</a:t>
             </a:r>
           </a:p>
         </p:txBody>
@@ -18760,7 +18694,7 @@
                 </a:solidFill>
                 <a:latin typeface="Calibri"/>
               </a:rPr>
-              <a:t>A dictionary-correct extraction earns a PASS. A flag survives only when a human genuinely needs to look at it.</a:t>
+              <a:t>PASS means nothing needs a second look. A warning stays up only when a person really should look at something.</a:t>
             </a:r>
           </a:p>
         </p:txBody>
@@ -18850,7 +18784,7 @@
                 </a:solidFill>
                 <a:latin typeface="Calibri"/>
               </a:rPr>
-              <a:t>Eval vs. the golden workbook</a:t>
+              <a:t>The score vs. the answer sheet</a:t>
             </a:r>
           </a:p>
           <a:p>
@@ -18872,7 +18806,7 @@
                 </a:solidFill>
                 <a:latin typeface="Calibri"/>
               </a:rPr>
-              <a:t>94.1% of cells match a hand-built reference. Every remaining cell is a difference deliberately built into the fixture.</a:t>
+              <a:t>94.1% of cells match a hand-made reference. The rest differ on purpose — we planted those differences to test the scoring.</a:t>
             </a:r>
           </a:p>
         </p:txBody>
@@ -18962,7 +18896,7 @@
                 </a:solidFill>
                 <a:latin typeface="Calibri"/>
               </a:rPr>
-              <a:t>The workbook itself</a:t>
+              <a:t>The spreadsheet itself</a:t>
             </a:r>
           </a:p>
           <a:p>
@@ -18984,7 +18918,7 @@
                 </a:solidFill>
                 <a:latin typeface="Calibri"/>
               </a:rPr>
-              <a:t>We download and open the .xlsx — the artifact a mapping analyst would otherwise hand-build.</a:t>
+              <a:t>We download and open the file — the thing a person would otherwise spend days making.</a:t>
             </a:r>
           </a:p>
         </p:txBody>
@@ -19119,7 +19053,7 @@
                 </a:solidFill>
                 <a:latin typeface="Calibri"/>
               </a:rPr>
-              <a:t>Honesty about the run</a:t>
+              <a:t>It tells you the cost first</a:t>
             </a:r>
           </a:p>
         </p:txBody>
@@ -19164,7 +19098,7 @@
                 </a:solidFill>
                 <a:latin typeface="Calibri"/>
               </a:rPr>
-              <a:t>The demo states its cost before it spends anything: one billed call, roughly $0.15, about thirty-five seconds.</a:t>
+              <a:t>Before running, it says exactly what it will spend: one paid AI call, about 15 cents, about 35 seconds.</a:t>
             </a:r>
           </a:p>
           <a:p>
@@ -19186,7 +19120,7 @@
                 </a:solidFill>
                 <a:latin typeface="Calibri"/>
               </a:rPr>
-              <a:t>Runs vary in how much the dictionary can auto-confirm. The mapping quality and the 94.1% eval have not varied.</a:t>
+              <a:t>Runs differ in how many questions get auto-answered. The spreadsheet and its 94.1% score haven't varied.</a:t>
             </a:r>
           </a:p>
         </p:txBody>
@@ -19321,7 +19255,7 @@
                 </a:solidFill>
                 <a:latin typeface="Calibri"/>
               </a:rPr>
-              <a:t>Data handling — non-negotiable</a:t>
+              <a:t>No real documents — ever</a:t>
             </a:r>
           </a:p>
         </p:txBody>
@@ -19366,7 +19300,7 @@
                 </a:solidFill>
                 <a:latin typeface="Calibri"/>
               </a:rPr>
-              <a:t>No real client document is used in this demo. The FRD on screen is anonymized and cleared for viewing.</a:t>
+              <a:t>The document on screen is scrubbed of anything real and approved for showing.</a:t>
             </a:r>
           </a:p>
           <a:p>
@@ -19388,7 +19322,7 @@
                 </a:solidFill>
                 <a:latin typeface="Calibri"/>
               </a:rPr>
-              <a:t>In the deployed shape, documents and outputs stay inside your own Databricks workspace and Unity Catalog volumes.</a:t>
+              <a:t>In real use, documents and results stay inside your own Databricks workspace and never leave it.</a:t>
             </a:r>
           </a:p>
         </p:txBody>
@@ -19662,7 +19596,7 @@
                 </a:solidFill>
                 <a:latin typeface="Calibri Light"/>
               </a:rPr>
-              <a:t>Measured on a live end-to-end run</a:t>
+              <a:t>Real numbers from a real run</a:t>
             </a:r>
           </a:p>
         </p:txBody>
@@ -19707,7 +19641,7 @@
                 </a:solidFill>
                 <a:latin typeface="Calibri"/>
               </a:rPr>
-              <a:t>Anonymized demo FRD → rendered workbook, on the committed pipeline, 7 August 2026. Not a mock run.</a:t>
+              <a:t>One scrubbed practice FRD, through the real pipeline, 7 August 2026. Nothing simulated.</a:t>
             </a:r>
           </a:p>
         </p:txBody>
@@ -19931,7 +19865,7 @@
                 </a:solidFill>
                 <a:latin typeface="Calibri"/>
               </a:rPr>
-              <a:t>MAPPING FIDELITY</a:t>
+              <a:t>SPREADSHEET MATCH</a:t>
             </a:r>
           </a:p>
           <a:p>
@@ -19953,7 +19887,7 @@
                 </a:solidFill>
                 <a:latin typeface="Calibri"/>
               </a:rPr>
-              <a:t>3,094 of 3,288 cells match the golden reference workbook</a:t>
+              <a:t>3,094 of 3,288 cells match the hand-made answer sheet</a:t>
             </a:r>
           </a:p>
         </p:txBody>
@@ -20133,7 +20067,7 @@
                 </a:solidFill>
                 <a:latin typeface="Calibri"/>
               </a:rPr>
-              <a:t>HALLUCINATION SWEEP</a:t>
+              <a:t>NOTHING MADE UP</a:t>
             </a:r>
           </a:p>
           <a:p>
@@ -20155,7 +20089,7 @@
                 </a:solidFill>
                 <a:latin typeface="Calibri"/>
               </a:rPr>
-              <a:t>Every identifier traced verbatim to the FRD or the workbook</a:t>
+              <a:t>Every name it wrote really appears in the source document</a:t>
             </a:r>
           </a:p>
         </p:txBody>
@@ -20335,7 +20269,7 @@
                 </a:solidFill>
                 <a:latin typeface="Calibri"/>
               </a:rPr>
-              <a:t>STRICT GROUNDING</a:t>
+              <a:t>SHOW-YOUR-WORK CHECKS</a:t>
             </a:r>
           </a:p>
           <a:p>
@@ -20357,7 +20291,7 @@
                 </a:solidFill>
                 <a:latin typeface="Calibri"/>
               </a:rPr>
-              <a:t>Plus 30 of 30 advisory checks — the quality gate passed clean</a:t>
+              <a:t>Plus all 30 softer checks — passed without one miss</a:t>
             </a:r>
           </a:p>
         </p:txBody>
@@ -20537,7 +20471,7 @@
                 </a:solidFill>
                 <a:latin typeface="Calibri"/>
               </a:rPr>
-              <a:t>END TO END</a:t>
+              <a:t>START TO FINISH</a:t>
             </a:r>
           </a:p>
           <a:p>
@@ -20559,7 +20493,7 @@
                 </a:solidFill>
                 <a:latin typeface="Calibri"/>
               </a:rPr>
-              <a:t>One billed model call, about $0.15 per document</a:t>
+              <a:t>One paid AI call, about 15 cents per document</a:t>
             </a:r>
           </a:p>
         </p:txBody>
@@ -20739,7 +20673,7 @@
                 </a:solidFill>
                 <a:latin typeface="Calibri"/>
               </a:rPr>
-              <a:t>Every one of the 194 non-matching cells is a datatype difference deliberately built into the test fixture. The eval catches exactly what it should.</a:t>
+              <a:t>All 194 non-matching cells are differences we planted on purpose, to prove the scoring notices them. It caught exactly those — nothing more.</a:t>
             </a:r>
           </a:p>
           <a:p>
@@ -20761,7 +20695,7 @@
                 </a:solidFill>
                 <a:latin typeface="Calibri"/>
               </a:rPr>
-              <a:t>No mapping was missed, and none was invented.</a:t>
+              <a:t>It missed nothing, and it invented nothing.</a:t>
             </a:r>
           </a:p>
           <a:p>
@@ -20783,7 +20717,7 @@
                 </a:solidFill>
                 <a:latin typeface="Calibri"/>
               </a:rPr>
-              <a:t>A proxy-SME review estimated a first-pass keep rate of roughly 96% — against an acceptance bar of 80%.</a:t>
+              <a:t>An expert reviewing the output would keep about 96% of it exactly as-is. The bar we had to clear was 80%.</a:t>
             </a:r>
           </a:p>
         </p:txBody>
@@ -20918,7 +20852,7 @@
                 </a:solidFill>
                 <a:latin typeface="Calibri"/>
               </a:rPr>
-              <a:t>Engineering posture</a:t>
+              <a:t>Built carefully</a:t>
             </a:r>
           </a:p>
         </p:txBody>
@@ -20963,7 +20897,7 @@
                 </a:solidFill>
                 <a:latin typeface="Calibri"/>
               </a:rPr>
-              <a:t>77 offline unit tests — no network, no model calls and no cluster needed to run them.</a:t>
+              <a:t>77 automatic tests that run with no internet, no AI calls and no cluster.</a:t>
             </a:r>
           </a:p>
           <a:p>
@@ -20985,7 +20919,7 @@
                 </a:solidFill>
                 <a:latin typeface="Calibri"/>
               </a:rPr>
-              <a:t>Headroom of roughly 75–90 feeds in one document; this run used 5% of its output budget.</a:t>
+              <a:t>It has room for a document with roughly 75–90 feeds; this one used just 5% of that room.</a:t>
             </a:r>
           </a:p>
           <a:p>
@@ -21007,7 +20941,7 @@
                 </a:solidFill>
                 <a:latin typeface="Calibri"/>
               </a:rPr>
-              <a:t>The pipeline fails loudly on schema violations, refusals or truncation — it never retries into a plausible answer.</a:t>
+              <a:t>When something is wrong it stops and says so, loudly. It never quietly retries its way to a nice-looking answer.</a:t>
             </a:r>
           </a:p>
         </p:txBody>

</xml_diff>